<commit_message>
Update RecursionIntroduction class materials
</commit_message>
<xml_diff>
--- a/ClassMaterials/RecursionIntroduction/Slides/Part1-Recursion.pptx
+++ b/ClassMaterials/RecursionIntroduction/Slides/Part1-Recursion.pptx
@@ -387,7 +387,7 @@
               <a:pPr>
                 <a:defRPr/>
               </a:pPr>
-              <a:t>4/22/2025</a:t>
+              <a:t>9/30/2026</a:t>
             </a:fld>
             <a:endParaRPr lang="en-US"/>
           </a:p>
@@ -622,7 +622,7 @@
               <a:pPr>
                 <a:defRPr/>
               </a:pPr>
-              <a:t>4/22/2025</a:t>
+              <a:t>9/30/2026</a:t>
             </a:fld>
             <a:endParaRPr lang="en-US"/>
           </a:p>
@@ -3425,7 +3425,7 @@
               <a:pPr>
                 <a:defRPr/>
               </a:pPr>
-              <a:t>Tuesday, April 22, 2025</a:t>
+              <a:t>Wednesday, September 30, 2026</a:t>
             </a:fld>
             <a:endParaRPr lang="en-US"/>
           </a:p>
@@ -3608,7 +3608,7 @@
               <a:pPr>
                 <a:defRPr/>
               </a:pPr>
-              <a:t>Tuesday, April 22, 2025</a:t>
+              <a:t>Wednesday, September 30, 2026</a:t>
             </a:fld>
             <a:endParaRPr lang="en-US"/>
           </a:p>
@@ -3801,7 +3801,7 @@
               <a:pPr>
                 <a:defRPr/>
               </a:pPr>
-              <a:t>Tuesday, April 22, 2025</a:t>
+              <a:t>Wednesday, September 30, 2026</a:t>
             </a:fld>
             <a:endParaRPr lang="en-US"/>
           </a:p>
@@ -3984,7 +3984,7 @@
               <a:pPr>
                 <a:defRPr/>
               </a:pPr>
-              <a:t>Tuesday, April 22, 2025</a:t>
+              <a:t>Wednesday, September 30, 2026</a:t>
             </a:fld>
             <a:endParaRPr lang="en-US"/>
           </a:p>
@@ -4244,7 +4244,7 @@
               <a:pPr>
                 <a:defRPr/>
               </a:pPr>
-              <a:t>Tuesday, April 22, 2025</a:t>
+              <a:t>Wednesday, September 30, 2026</a:t>
             </a:fld>
             <a:endParaRPr lang="en-US"/>
           </a:p>
@@ -4544,7 +4544,7 @@
               <a:pPr>
                 <a:defRPr/>
               </a:pPr>
-              <a:t>Tuesday, April 22, 2025</a:t>
+              <a:t>Wednesday, September 30, 2026</a:t>
             </a:fld>
             <a:endParaRPr lang="en-US"/>
           </a:p>
@@ -4978,7 +4978,7 @@
               <a:pPr>
                 <a:defRPr/>
               </a:pPr>
-              <a:t>Tuesday, April 22, 2025</a:t>
+              <a:t>Wednesday, September 30, 2026</a:t>
             </a:fld>
             <a:endParaRPr lang="en-US"/>
           </a:p>
@@ -5110,7 +5110,7 @@
               <a:pPr>
                 <a:defRPr/>
               </a:pPr>
-              <a:t>Tuesday, April 22, 2025</a:t>
+              <a:t>Wednesday, September 30, 2026</a:t>
             </a:fld>
             <a:endParaRPr lang="en-US"/>
           </a:p>
@@ -5220,7 +5220,7 @@
               <a:pPr>
                 <a:defRPr/>
               </a:pPr>
-              <a:t>Tuesday, April 22, 2025</a:t>
+              <a:t>Wednesday, September 30, 2026</a:t>
             </a:fld>
             <a:endParaRPr lang="en-US"/>
           </a:p>
@@ -5510,7 +5510,7 @@
               <a:pPr>
                 <a:defRPr/>
               </a:pPr>
-              <a:t>Tuesday, April 22, 2025</a:t>
+              <a:t>Wednesday, September 30, 2026</a:t>
             </a:fld>
             <a:endParaRPr lang="en-US"/>
           </a:p>
@@ -5777,7 +5777,7 @@
               <a:pPr>
                 <a:defRPr/>
               </a:pPr>
-              <a:t>Tuesday, April 22, 2025</a:t>
+              <a:t>Wednesday, September 30, 2026</a:t>
             </a:fld>
             <a:endParaRPr lang="en-US"/>
           </a:p>
@@ -6003,7 +6003,7 @@
               <a:pPr>
                 <a:defRPr/>
               </a:pPr>
-              <a:t>Tuesday, April 22, 2025</a:t>
+              <a:t>Wednesday, September 30, 2026</a:t>
             </a:fld>
             <a:endParaRPr lang="en-US"/>
           </a:p>
@@ -6464,12 +6464,14 @@
         </p:nvSpPr>
         <p:spPr>
           <a:xfrm>
-            <a:off x="2124075" y="3909848"/>
+            <a:off x="1502285" y="3368121"/>
             <a:ext cx="6400800" cy="1752600"/>
           </a:xfrm>
         </p:spPr>
         <p:txBody>
-          <a:bodyPr/>
+          <a:bodyPr>
+            <a:normAutofit/>
+          </a:bodyPr>
           <a:lstStyle/>
           <a:p>
             <a:pPr marR="0" eaLnBrk="1" hangingPunct="1">
@@ -6478,7 +6480,7 @@
               </a:lnSpc>
             </a:pPr>
             <a:r>
-              <a:rPr lang="en-US" sz="2500" dirty="0"/>
+              <a:rPr lang="en-US" dirty="0"/>
               <a:t>Recursion</a:t>
             </a:r>
           </a:p>
@@ -6560,7 +6562,7 @@
             </a:pPr>
             <a:r>
               <a:rPr lang="en-US" sz="2400" i="1" dirty="0" err="1"/>
-              <a:t>PracticeRecursionInClass</a:t>
+              <a:t>PracticeRecursion</a:t>
             </a:r>
             <a:endParaRPr lang="en-US" sz="2400" i="1" dirty="0"/>
           </a:p>
@@ -6571,79 +6573,12 @@
             </a:pPr>
             <a:r>
               <a:rPr lang="en-US" sz="2400" i="1" dirty="0" err="1"/>
-              <a:t>PracticeSolutionRecursionInClass</a:t>
+              <a:t>PracticeRecursionSolution</a:t>
             </a:r>
             <a:endParaRPr lang="en-US" sz="2400" i="1" dirty="0"/>
           </a:p>
-          <a:p>
-            <a:r>
-              <a:rPr lang="en-US" sz="2400" dirty="0">
-                <a:solidFill>
-                  <a:srgbClr val="FFFFFF"/>
-                </a:solidFill>
-              </a:rPr>
-              <a:t>The </a:t>
-            </a:r>
-            <a:r>
-              <a:rPr lang="en-US" sz="2400" i="1" dirty="0">
-                <a:solidFill>
-                  <a:srgbClr val="FFFFFF"/>
-                </a:solidFill>
-              </a:rPr>
-              <a:t>Quiz </a:t>
-            </a:r>
-            <a:r>
-              <a:rPr lang="en-US" sz="2400" dirty="0">
-                <a:solidFill>
-                  <a:srgbClr val="FFFFFF"/>
-                </a:solidFill>
-              </a:rPr>
-              <a:t>for today is:</a:t>
-            </a:r>
-          </a:p>
-          <a:p>
-            <a:pPr marL="342900" indent="-342900">
-              <a:buFont typeface="Arial" panose="020B0604020202020204" pitchFamily="34" charset="0"/>
-              <a:buChar char="•"/>
-            </a:pPr>
-            <a:r>
-              <a:rPr lang="en-US" sz="2400" i="1" dirty="0" err="1"/>
-              <a:t>RecursionIntroductionQuiz</a:t>
-            </a:r>
-            <a:endParaRPr lang="en-US" sz="2400" i="1" dirty="0"/>
-          </a:p>
-        </p:txBody>
-      </p:sp>
-      <p:pic>
-        <p:nvPicPr>
-          <p:cNvPr id="4" name="Picture 3">
-            <a:extLst>
-              <a:ext uri="{FF2B5EF4-FFF2-40B4-BE49-F238E27FC236}">
-                <a16:creationId xmlns:a16="http://schemas.microsoft.com/office/drawing/2014/main" id="{0F42B4CB-7915-60F5-90D7-3560C4914127}"/>
-              </a:ext>
-            </a:extLst>
-          </p:cNvPr>
-          <p:cNvPicPr>
-            <a:picLocks noChangeAspect="1"/>
-          </p:cNvPicPr>
-          <p:nvPr/>
-        </p:nvPicPr>
-        <p:blipFill>
-          <a:blip r:embed="rId4"/>
-          <a:stretch>
-            <a:fillRect/>
-          </a:stretch>
-        </p:blipFill>
-        <p:spPr>
-          <a:xfrm>
-            <a:off x="6213087" y="1328037"/>
-            <a:ext cx="2816626" cy="2439173"/>
-          </a:xfrm>
-          <a:prstGeom prst="rect">
-            <a:avLst/>
-          </a:prstGeom>
-        </p:spPr>
-      </p:pic>
+        </p:txBody>
+      </p:sp>
       <p:pic>
         <p:nvPicPr>
           <p:cNvPr id="7" name="Picture 6" descr="A blue triangle with black background&#10;&#10;Description automatically generated">
@@ -6659,7 +6594,7 @@
           <p:nvPr/>
         </p:nvPicPr>
         <p:blipFill>
-          <a:blip r:embed="rId5">
+          <a:blip r:embed="rId4">
             <a:extLst>
               <a:ext uri="{28A0092B-C50C-407E-A947-70E740481C1C}">
                 <a14:useLocalDpi xmlns:a14="http://schemas.microsoft.com/office/drawing/2010/main" val="0"/>
@@ -6672,7 +6607,7 @@
         </p:blipFill>
         <p:spPr>
           <a:xfrm>
-            <a:off x="3419474" y="209270"/>
+            <a:off x="6697941" y="201883"/>
             <a:ext cx="2141259" cy="2151965"/>
           </a:xfrm>
           <a:prstGeom prst="rect">
@@ -6680,69 +6615,6 @@
           </a:prstGeom>
         </p:spPr>
       </p:pic>
-      <p:sp>
-        <p:nvSpPr>
-          <p:cNvPr id="5" name="Shape 54">
-            <a:extLst>
-              <a:ext uri="{FF2B5EF4-FFF2-40B4-BE49-F238E27FC236}">
-                <a16:creationId xmlns:a16="http://schemas.microsoft.com/office/drawing/2014/main" id="{6E981362-77F6-CAEB-2653-3129046FA390}"/>
-              </a:ext>
-            </a:extLst>
-          </p:cNvPr>
-          <p:cNvSpPr/>
-          <p:nvPr/>
-        </p:nvSpPr>
-        <p:spPr>
-          <a:xfrm>
-            <a:off x="5672507" y="120198"/>
-            <a:ext cx="3346430" cy="738664"/>
-          </a:xfrm>
-          <a:prstGeom prst="rect">
-            <a:avLst/>
-          </a:prstGeom>
-          <a:solidFill>
-            <a:srgbClr val="9BBB59"/>
-          </a:solidFill>
-          <a:ln w="25400" cap="rnd">
-            <a:solidFill>
-              <a:srgbClr val="718841"/>
-            </a:solidFill>
-          </a:ln>
-          <a:extLst>
-            <a:ext uri="{C572A759-6A51-4108-AA02-DFA0A04FC94B}">
-              <ma14:wrappingTextBoxFlag xmlns:ma14="http://schemas.microsoft.com/office/mac/drawingml/2011/main" xmlns="" val="1"/>
-            </a:ext>
-          </a:extLst>
-        </p:spPr>
-        <p:txBody>
-          <a:bodyPr wrap="square" lIns="0" tIns="0" rIns="0" bIns="0">
-            <a:spAutoFit/>
-          </a:bodyPr>
-          <a:lstStyle/>
-          <a:p>
-            <a:pPr lvl="0"/>
-            <a:r>
-              <a:rPr lang="en-US" sz="2400" i="1" dirty="0">
-                <a:solidFill>
-                  <a:srgbClr val="FFFFFF"/>
-                </a:solidFill>
-              </a:rPr>
-              <a:t> Attendance password    </a:t>
-            </a:r>
-          </a:p>
-          <a:p>
-            <a:pPr lvl="0"/>
-            <a:r>
-              <a:rPr lang="en-US" sz="2400" i="1" dirty="0">
-                <a:solidFill>
-                  <a:srgbClr val="FFFFFF"/>
-                </a:solidFill>
-              </a:rPr>
-              <a:t> is written on the board</a:t>
-            </a:r>
-          </a:p>
-        </p:txBody>
-      </p:sp>
     </p:spTree>
   </p:cSld>
   <p:clrMapOvr>
@@ -8463,15 +8335,25 @@
             <a:pPr lvl="1"/>
             <a:r>
               <a:rPr lang="en-US" dirty="0"/>
-              <a:t>A new way to break up and re-use code: </a:t>
-            </a:r>
+              <a:t>New ways to break up and re-use code:</a:t>
+            </a:r>
+          </a:p>
+          <a:p>
+            <a:pPr lvl="2"/>
+            <a:r>
+              <a:rPr lang="en-US" b="1" dirty="0"/>
+              <a:t>Inheritance</a:t>
+            </a:r>
+          </a:p>
+          <a:p>
+            <a:pPr lvl="2"/>
             <a:r>
               <a:rPr lang="en-US" b="1" dirty="0"/>
               <a:t>Interfaces</a:t>
             </a:r>
           </a:p>
           <a:p>
-            <a:pPr lvl="2"/>
+            <a:pPr lvl="3"/>
             <a:r>
               <a:rPr lang="en-US" dirty="0"/>
               <a:t>Making interactive apps requires this</a:t>
@@ -10539,13 +10421,13 @@
         </p:spPr>
         <p:txBody>
           <a:bodyPr>
-            <a:normAutofit fontScale="90000"/>
+            <a:normAutofit/>
           </a:bodyPr>
           <a:lstStyle/>
           <a:p>
             <a:r>
               <a:rPr lang="en-US" dirty="0"/>
-              <a:t>Open Eclipse</a:t>
+              <a:t>Open IntelliJ</a:t>
             </a:r>
           </a:p>
         </p:txBody>
@@ -12111,7 +11993,7 @@
           <a:p>
             <a:r>
               <a:rPr lang="en-US" dirty="0"/>
-              <a:t>Open Today’s Quiz</a:t>
+              <a:t>Recursive Stack Frame Tracing</a:t>
             </a:r>
           </a:p>
         </p:txBody>

</xml_diff>